<commit_message>
started updates on week 10
</commit_message>
<xml_diff>
--- a/topic10-interfaces/unit-10a-lectures/talk-1-ddd/a-deadly-diamond-of-death.pptx
+++ b/topic10-interfaces/unit-10a-lectures/talk-1-ddd/a-deadly-diamond-of-death.pptx
@@ -235,7 +235,7 @@
           <a:p>
             <a:fld id="{56BC3C30-7F3D-4B20-9974-47C57B22CA6E}" type="datetimeFigureOut">
               <a:rPr lang="en-IE" smtClean="0"/>
-              <a:t>19/03/2024</a:t>
+              <a:t>09/04/2026</a:t>
             </a:fld>
             <a:endParaRPr lang="en-IE"/>
           </a:p>
@@ -1219,7 +1219,7 @@
             <a:fld id="{1D8BD707-D9CF-40AE-B4C6-C98DA3205C09}" type="datetimeFigureOut">
               <a:rPr lang="en-US" smtClean="0"/>
               <a:pPr/>
-              <a:t>3/19/24</a:t>
+              <a:t>4/9/2026</a:t>
             </a:fld>
             <a:endParaRPr lang="en-US"/>
           </a:p>
@@ -1384,7 +1384,7 @@
             <a:fld id="{1D8BD707-D9CF-40AE-B4C6-C98DA3205C09}" type="datetimeFigureOut">
               <a:rPr lang="en-US" smtClean="0"/>
               <a:pPr/>
-              <a:t>3/19/24</a:t>
+              <a:t>4/9/2026</a:t>
             </a:fld>
             <a:endParaRPr lang="en-US"/>
           </a:p>
@@ -1559,7 +1559,7 @@
             <a:fld id="{1D8BD707-D9CF-40AE-B4C6-C98DA3205C09}" type="datetimeFigureOut">
               <a:rPr lang="en-US" smtClean="0"/>
               <a:pPr/>
-              <a:t>3/19/24</a:t>
+              <a:t>4/9/2026</a:t>
             </a:fld>
             <a:endParaRPr lang="en-US"/>
           </a:p>
@@ -1735,7 +1735,7 @@
           </a:ln>
           <a:extLst>
             <a:ext uri="{C572A759-6A51-4108-AA02-DFA0A04FC94B}">
-              <ma14:wrappingTextBoxFlag xmlns:ma14="http://schemas.microsoft.com/office/mac/drawingml/2011/main" xmlns="" val="1"/>
+              <ma14:wrappingTextBoxFlag xmlns="" xmlns:ma14="http://schemas.microsoft.com/office/mac/drawingml/2011/main" val="1"/>
             </a:ext>
           </a:extLst>
         </p:spPr>
@@ -1822,7 +1822,7 @@
             <a:effectLst/>
             <a:extLst>
               <a:ext uri="{C572A759-6A51-4108-AA02-DFA0A04FC94B}">
-                <ma14:wrappingTextBoxFlag xmlns:ma14="http://schemas.microsoft.com/office/mac/drawingml/2011/main" xmlns="" val="1"/>
+                <ma14:wrappingTextBoxFlag xmlns="" xmlns:ma14="http://schemas.microsoft.com/office/mac/drawingml/2011/main" val="1"/>
               </a:ext>
             </a:extLst>
           </p:spPr>
@@ -1895,7 +1895,7 @@
             <a:effectLst/>
             <a:extLst>
               <a:ext uri="{C572A759-6A51-4108-AA02-DFA0A04FC94B}">
-                <ma14:wrappingTextBoxFlag xmlns:ma14="http://schemas.microsoft.com/office/mac/drawingml/2011/main" xmlns="" val="1"/>
+                <ma14:wrappingTextBoxFlag xmlns="" xmlns:ma14="http://schemas.microsoft.com/office/mac/drawingml/2011/main" val="1"/>
               </a:ext>
             </a:extLst>
           </p:spPr>
@@ -1946,7 +1946,7 @@
             <a:effectLst/>
             <a:extLst>
               <a:ext uri="{C572A759-6A51-4108-AA02-DFA0A04FC94B}">
-                <ma14:wrappingTextBoxFlag xmlns:ma14="http://schemas.microsoft.com/office/mac/drawingml/2011/main" xmlns="" val="1"/>
+                <ma14:wrappingTextBoxFlag xmlns="" xmlns:ma14="http://schemas.microsoft.com/office/mac/drawingml/2011/main" val="1"/>
               </a:ext>
             </a:extLst>
           </p:spPr>
@@ -2339,7 +2339,7 @@
             <a:fld id="{1D8BD707-D9CF-40AE-B4C6-C98DA3205C09}" type="datetimeFigureOut">
               <a:rPr lang="en-US" smtClean="0"/>
               <a:pPr/>
-              <a:t>3/19/24</a:t>
+              <a:t>4/9/2026</a:t>
             </a:fld>
             <a:endParaRPr lang="en-US"/>
           </a:p>
@@ -2619,7 +2619,7 @@
             <a:fld id="{1D8BD707-D9CF-40AE-B4C6-C98DA3205C09}" type="datetimeFigureOut">
               <a:rPr lang="en-US" smtClean="0"/>
               <a:pPr/>
-              <a:t>3/19/24</a:t>
+              <a:t>4/9/2026</a:t>
             </a:fld>
             <a:endParaRPr lang="en-US"/>
           </a:p>
@@ -2912,7 +2912,7 @@
             <a:fld id="{1D8BD707-D9CF-40AE-B4C6-C98DA3205C09}" type="datetimeFigureOut">
               <a:rPr lang="en-US" smtClean="0"/>
               <a:pPr/>
-              <a:t>3/19/24</a:t>
+              <a:t>4/9/2026</a:t>
             </a:fld>
             <a:endParaRPr lang="en-US"/>
           </a:p>
@@ -3370,7 +3370,7 @@
             <a:fld id="{1D8BD707-D9CF-40AE-B4C6-C98DA3205C09}" type="datetimeFigureOut">
               <a:rPr lang="en-US" smtClean="0"/>
               <a:pPr/>
-              <a:t>3/19/24</a:t>
+              <a:t>4/9/2026</a:t>
             </a:fld>
             <a:endParaRPr lang="en-US"/>
           </a:p>
@@ -3530,7 +3530,7 @@
             <a:fld id="{1D8BD707-D9CF-40AE-B4C6-C98DA3205C09}" type="datetimeFigureOut">
               <a:rPr lang="en-US" smtClean="0"/>
               <a:pPr/>
-              <a:t>3/19/24</a:t>
+              <a:t>4/9/2026</a:t>
             </a:fld>
             <a:endParaRPr lang="en-US"/>
           </a:p>
@@ -3657,7 +3657,7 @@
             <a:fld id="{1D8BD707-D9CF-40AE-B4C6-C98DA3205C09}" type="datetimeFigureOut">
               <a:rPr lang="en-US" smtClean="0"/>
               <a:pPr/>
-              <a:t>3/19/24</a:t>
+              <a:t>4/9/2026</a:t>
             </a:fld>
             <a:endParaRPr lang="en-US"/>
           </a:p>
@@ -3929,7 +3929,7 @@
             <a:fld id="{1D8BD707-D9CF-40AE-B4C6-C98DA3205C09}" type="datetimeFigureOut">
               <a:rPr lang="en-US" smtClean="0"/>
               <a:pPr/>
-              <a:t>3/19/24</a:t>
+              <a:t>4/9/2026</a:t>
             </a:fld>
             <a:endParaRPr lang="en-US"/>
           </a:p>
@@ -4178,7 +4178,7 @@
             <a:fld id="{1D8BD707-D9CF-40AE-B4C6-C98DA3205C09}" type="datetimeFigureOut">
               <a:rPr lang="en-US" smtClean="0"/>
               <a:pPr/>
-              <a:t>3/19/24</a:t>
+              <a:t>4/9/2026</a:t>
             </a:fld>
             <a:endParaRPr lang="en-US"/>
           </a:p>
@@ -4386,7 +4386,7 @@
             <a:fld id="{1D8BD707-D9CF-40AE-B4C6-C98DA3205C09}" type="datetimeFigureOut">
               <a:rPr lang="en-US" smtClean="0"/>
               <a:pPr/>
-              <a:t>3/19/24</a:t>
+              <a:t>4/9/2026</a:t>
             </a:fld>
             <a:endParaRPr lang="en-US"/>
           </a:p>
@@ -5116,7 +5116,7 @@
           <p:nvPr/>
         </p:nvPicPr>
         <p:blipFill>
-          <a:blip r:embed="rId3">
+          <a:blip r:embed="rId3" cstate="print">
             <a:extLst>
               <a:ext uri="{28A0092B-C50C-407E-A947-70E740481C1C}">
                 <a14:useLocalDpi xmlns:a14="http://schemas.microsoft.com/office/drawing/2010/main" val="0"/>
@@ -8818,6 +8818,14 @@
 <file path=ppt/slides/slide25.xml><?xml version="1.0" encoding="utf-8"?>
 <p:sld xmlns:a="http://schemas.openxmlformats.org/drawingml/2006/main" xmlns:r="http://schemas.openxmlformats.org/officeDocument/2006/relationships" xmlns:p="http://schemas.openxmlformats.org/presentationml/2006/main">
   <p:cSld>
+    <p:bg>
+      <p:bgPr>
+        <a:solidFill>
+          <a:schemeClr val="bg1"/>
+        </a:solidFill>
+        <a:effectLst/>
+      </p:bgPr>
+    </p:bg>
     <p:spTree>
       <p:nvGrpSpPr>
         <p:cNvPr id="1" name=""/>
@@ -8832,66 +8840,91 @@
           <a:chExt cx="0" cy="0"/>
         </a:xfrm>
       </p:grpSpPr>
-      <p:pic>
-        <p:nvPicPr>
-          <p:cNvPr id="8194" name="Picture 2" descr="C:\Users\Siobhan\AppData\Local\Microsoft\Windows\Temporary Internet Files\Content.IE5\D6SFLNVW\questions-2[1].jpg"/>
-          <p:cNvPicPr>
-            <a:picLocks noChangeAspect="1" noChangeArrowheads="1"/>
-          </p:cNvPicPr>
-          <p:nvPr/>
-        </p:nvPicPr>
-        <p:blipFill>
-          <a:blip r:embed="rId3">
+      <p:sp>
+        <p:nvSpPr>
+          <p:cNvPr id="8" name="Down Arrow 7">
             <a:extLst>
-              <a:ext uri="{28A0092B-C50C-407E-A947-70E740481C1C}">
-                <a14:useLocalDpi xmlns:a14="http://schemas.microsoft.com/office/drawing/2010/main" val="0"/>
+              <a:ext uri="{FF2B5EF4-FFF2-40B4-BE49-F238E27FC236}">
+                <a16:creationId xmlns:a16="http://schemas.microsoft.com/office/drawing/2014/main" id="{D4771268-CB57-404A-9271-370EB28F6090}"/>
+              </a:ext>
+              <a:ext uri="{C183D7F6-B498-43B3-948B-1728B52AA6E4}">
+                <adec:decorative xmlns:adec="http://schemas.microsoft.com/office/drawing/2017/decorative" val="1"/>
               </a:ext>
             </a:extLst>
-          </a:blip>
-          <a:srcRect/>
-          <a:stretch>
-            <a:fillRect/>
-          </a:stretch>
-        </p:blipFill>
-        <p:spPr bwMode="auto">
+          </p:cNvPr>
+          <p:cNvSpPr>
+            <a:spLocks noGrp="1" noRot="1" noChangeAspect="1" noMove="1" noResize="1" noEditPoints="1" noAdjustHandles="1" noChangeArrowheads="1" noChangeShapeType="1" noTextEdit="1"/>
+          </p:cNvSpPr>
+          <p:nvPr>
+            <p:extLst>
+              <p:ext uri="{386F3935-93C4-4BCD-93E2-E3B085C9AB24}">
+                <p16:designElem xmlns:p16="http://schemas.microsoft.com/office/powerpoint/2015/main" val="1"/>
+              </p:ext>
+            </p:extLst>
+          </p:nvPr>
+        </p:nvSpPr>
+        <p:spPr>
+          <a:xfrm rot="16200000">
+            <a:off x="800100" y="1491343"/>
+            <a:ext cx="3333749" cy="3499103"/>
+          </a:xfrm>
+          <a:prstGeom prst="downArrow">
+            <a:avLst>
+              <a:gd name="adj1" fmla="val 100000"/>
+              <a:gd name="adj2" fmla="val 15788"/>
+            </a:avLst>
+          </a:prstGeom>
+          <a:solidFill>
+            <a:srgbClr val="404040"/>
+          </a:solidFill>
+          <a:ln w="53975">
+            <a:noFill/>
+          </a:ln>
+        </p:spPr>
+        <p:style>
+          <a:lnRef idx="2">
+            <a:schemeClr val="accent1">
+              <a:shade val="50000"/>
+            </a:schemeClr>
+          </a:lnRef>
+          <a:fillRef idx="1">
+            <a:schemeClr val="accent1"/>
+          </a:fillRef>
+          <a:effectRef idx="0">
+            <a:schemeClr val="accent1"/>
+          </a:effectRef>
+          <a:fontRef idx="minor">
+            <a:schemeClr val="lt1"/>
+          </a:fontRef>
+        </p:style>
+        <p:txBody>
+          <a:bodyPr rtlCol="0" anchor="ctr"/>
+          <a:lstStyle/>
+          <a:p>
+            <a:pPr algn="ctr"/>
+            <a:endParaRPr lang="en-US"/>
+          </a:p>
+        </p:txBody>
+      </p:sp>
+      <p:sp>
+        <p:nvSpPr>
+          <p:cNvPr id="2" name="Rectangle 1"/>
+          <p:cNvSpPr/>
+          <p:nvPr/>
+        </p:nvSpPr>
+        <p:spPr>
           <a:xfrm>
-            <a:off x="5492403" y="1371600"/>
-            <a:ext cx="4394200" cy="4394200"/>
+            <a:off x="1028700" y="1967266"/>
+            <a:ext cx="2628900" cy="2547257"/>
           </a:xfrm>
           <a:prstGeom prst="rect">
             <a:avLst/>
           </a:prstGeom>
           <a:noFill/>
-          <a:extLst>
-            <a:ext uri="{909E8E84-426E-40DD-AFC4-6F175D3DCCD1}">
-              <a14:hiddenFill xmlns:a14="http://schemas.microsoft.com/office/drawing/2010/main">
-                <a:solidFill>
-                  <a:srgbClr val="FFFFFF"/>
-                </a:solidFill>
-              </a14:hiddenFill>
-            </a:ext>
-          </a:extLst>
-        </p:spPr>
-      </p:pic>
-      <p:sp>
-        <p:nvSpPr>
-          <p:cNvPr id="2" name="Rectangle 1"/>
-          <p:cNvSpPr/>
-          <p:nvPr/>
-        </p:nvSpPr>
-        <p:spPr>
-          <a:xfrm>
-            <a:off x="2514601" y="2741474"/>
-            <a:ext cx="3485803" cy="1754326"/>
-          </a:xfrm>
-          <a:prstGeom prst="rect">
-            <a:avLst/>
-          </a:prstGeom>
-          <a:noFill/>
-        </p:spPr>
-        <p:txBody>
-          <a:bodyPr wrap="square" lIns="91440" tIns="45720" rIns="91440" bIns="45720">
-            <a:spAutoFit/>
+        </p:spPr>
+        <p:txBody>
+          <a:bodyPr vert="horz" lIns="91440" tIns="45720" rIns="91440" bIns="45720" rtlCol="0" anchor="ctr">
+            <a:normAutofit/>
             <a:scene3d>
               <a:camera prst="orthographicFront"/>
               <a:lightRig rig="flat" dir="tl">
@@ -8909,35 +8942,23 @@
           </a:bodyPr>
           <a:lstStyle/>
           <a:p>
-            <a:pPr algn="ctr"/>
-            <a:r>
-              <a:rPr lang="en-US" sz="5400" b="1" dirty="0">
+            <a:pPr algn="ctr">
+              <a:lnSpc>
+                <a:spcPct val="90000"/>
+              </a:lnSpc>
+              <a:spcBef>
+                <a:spcPct val="0"/>
+              </a:spcBef>
+              <a:spcAft>
+                <a:spcPts val="600"/>
+              </a:spcAft>
+            </a:pPr>
+            <a:r>
+              <a:rPr lang="en-US" sz="3600" b="1" kern="1200">
                 <a:ln w="11430"/>
-                <a:gradFill>
-                  <a:gsLst>
-                    <a:gs pos="0">
-                      <a:schemeClr val="accent2">
-                        <a:tint val="70000"/>
-                        <a:satMod val="245000"/>
-                      </a:schemeClr>
-                    </a:gs>
-                    <a:gs pos="75000">
-                      <a:schemeClr val="accent2">
-                        <a:tint val="90000"/>
-                        <a:shade val="60000"/>
-                        <a:satMod val="240000"/>
-                      </a:schemeClr>
-                    </a:gs>
-                    <a:gs pos="100000">
-                      <a:schemeClr val="accent2">
-                        <a:tint val="100000"/>
-                        <a:shade val="50000"/>
-                        <a:satMod val="240000"/>
-                      </a:schemeClr>
-                    </a:gs>
-                  </a:gsLst>
-                  <a:lin ang="5400000"/>
-                </a:gradFill>
+                <a:solidFill>
+                  <a:srgbClr val="FFFFFF"/>
+                </a:solidFill>
                 <a:effectLst>
                   <a:outerShdw blurRad="50800" dist="39000" dir="5460000" algn="tl">
                     <a:srgbClr val="000000">
@@ -8945,12 +8966,52 @@
                     </a:srgbClr>
                   </a:outerShdw>
                 </a:effectLst>
+                <a:latin typeface="+mj-lt"/>
+                <a:ea typeface="+mj-ea"/>
+                <a:cs typeface="+mj-cs"/>
               </a:rPr>
               <a:t>Any Questions?</a:t>
             </a:r>
           </a:p>
         </p:txBody>
       </p:sp>
+      <p:pic>
+        <p:nvPicPr>
+          <p:cNvPr id="3" name="Picture 2" descr="A green question mark in a circle&#10;&#10;AI-generated content may be incorrect.">
+            <a:extLst>
+              <a:ext uri="{FF2B5EF4-FFF2-40B4-BE49-F238E27FC236}">
+                <a16:creationId xmlns:a16="http://schemas.microsoft.com/office/drawing/2014/main" id="{CF860B98-D563-7CBE-980D-77BC51543A84}"/>
+              </a:ext>
+            </a:extLst>
+          </p:cNvPr>
+          <p:cNvPicPr>
+            <a:picLocks noChangeAspect="1"/>
+          </p:cNvPicPr>
+          <p:nvPr/>
+        </p:nvPicPr>
+        <p:blipFill>
+          <a:blip r:embed="rId3">
+            <a:extLst>
+              <a:ext uri="{28A0092B-C50C-407E-A947-70E740481C1C}">
+                <a14:useLocalDpi xmlns:a14="http://schemas.microsoft.com/office/drawing/2010/main" val="0"/>
+              </a:ext>
+            </a:extLst>
+          </a:blip>
+          <a:stretch>
+            <a:fillRect/>
+          </a:stretch>
+        </p:blipFill>
+        <p:spPr>
+          <a:xfrm>
+            <a:off x="5383296" y="643466"/>
+            <a:ext cx="5568739" cy="5568739"/>
+          </a:xfrm>
+          <a:prstGeom prst="rect">
+            <a:avLst/>
+          </a:prstGeom>
+          <a:noFill/>
+        </p:spPr>
+      </p:pic>
     </p:spTree>
     <p:custDataLst>
       <p:tags r:id="rId1"/>

</xml_diff>